<commit_message>
Add demo dashboard: FastAPI backend, web frontend, and view seeding
- server/: FastAPI app with config, datasets, runner, simulate, snapshot, views modules
- web/: dashboard HTML, JS (SVG charting + API integration), DataZymes-branded styles
- tests/: pytest suite covering API, config, datasets, runner, simulate, snapshot, views, seeding
- scripts/seed_views.py + views.yaml: view registry as single source of truth for dashboard cards
- run_dashboard.py launcher, pytest.ini (slow marker)
- Update demo-dashboard spec/plan docs; regenerate run_001/run_002 decks
- Add skyrizi/tremfya IBD-split analysis run outputs

Co-Authored-By: Claude Opus 4.8 (1M context) <noreply@anthropic.com>
</commit_message>
<xml_diff>
--- a/output/run_2026-06-08_001/deck.pptx
+++ b/output/run_2026-06-08_001/deck.pptx
@@ -6,7 +6,6 @@
   </p:sldMasterIdLst>
   <p:sldIdLst>
     <p:sldId id="256" r:id="rId7"/>
-    <p:sldId id="257" r:id="rId8"/>
   </p:sldIdLst>
   <p:sldSz cx="12191695" cy="6858000" type="screen4x3"/>
   <p:notesSz cx="6858000" cy="9144000"/>
@@ -4586,316 +4585,6 @@
             <a:avLst/>
           </a:prstGeom>
           <a:solidFill>
-            <a:srgbClr val="071D49"/>
-          </a:solidFill>
-          <a:ln>
-            <a:noFill/>
-          </a:ln>
-          <a:effectLst/>
-        </p:spPr>
-        <p:style>
-          <a:lnRef idx="1">
-            <a:schemeClr val="accent1"/>
-          </a:lnRef>
-          <a:fillRef idx="3">
-            <a:schemeClr val="accent1"/>
-          </a:fillRef>
-          <a:effectRef idx="2">
-            <a:schemeClr val="accent1"/>
-          </a:effectRef>
-          <a:fontRef idx="minor">
-            <a:schemeClr val="lt1"/>
-          </a:fontRef>
-        </p:style>
-        <p:txBody>
-          <a:bodyPr rtlCol="0" anchor="ctr"/>
-          <a:lstStyle/>
-          <a:p>
-            <a:pPr algn="ctr"/>
-          </a:p>
-        </p:txBody>
-      </p:sp>
-      <p:sp>
-        <p:nvSpPr>
-          <p:cNvPr id="3" name="Rectangle 2"/>
-          <p:cNvSpPr/>
-          <p:nvPr/>
-        </p:nvSpPr>
-        <p:spPr>
-          <a:xfrm>
-            <a:off x="411480" y="2331720"/>
-            <a:ext cx="822960" cy="82296"/>
-          </a:xfrm>
-          <a:prstGeom prst="rect">
-            <a:avLst/>
-          </a:prstGeom>
-          <a:solidFill>
-            <a:srgbClr val="E40D62"/>
-          </a:solidFill>
-          <a:ln>
-            <a:noFill/>
-          </a:ln>
-          <a:effectLst/>
-        </p:spPr>
-        <p:style>
-          <a:lnRef idx="1">
-            <a:schemeClr val="accent1"/>
-          </a:lnRef>
-          <a:fillRef idx="3">
-            <a:schemeClr val="accent1"/>
-          </a:fillRef>
-          <a:effectRef idx="2">
-            <a:schemeClr val="accent1"/>
-          </a:effectRef>
-          <a:fontRef idx="minor">
-            <a:schemeClr val="lt1"/>
-          </a:fontRef>
-        </p:style>
-        <p:txBody>
-          <a:bodyPr rtlCol="0" anchor="ctr"/>
-          <a:lstStyle/>
-          <a:p>
-            <a:pPr algn="ctr"/>
-          </a:p>
-        </p:txBody>
-      </p:sp>
-      <p:sp>
-        <p:nvSpPr>
-          <p:cNvPr id="4" name="TextBox 3"/>
-          <p:cNvSpPr txBox="1"/>
-          <p:nvPr/>
-        </p:nvSpPr>
-        <p:spPr>
-          <a:xfrm>
-            <a:off x="411480" y="1463040"/>
-            <a:ext cx="7315200" cy="365760"/>
-          </a:xfrm>
-          <a:prstGeom prst="rect">
-            <a:avLst/>
-          </a:prstGeom>
-          <a:noFill/>
-        </p:spPr>
-        <p:txBody>
-          <a:bodyPr wrap="square" anchor="t" lIns="0" rIns="0" tIns="0" bIns="0">
-            <a:spAutoFit/>
-          </a:bodyPr>
-          <a:lstStyle/>
-          <a:p>
-            <a:pPr algn="l">
-              <a:lnSpc>
-                <a:spcPct val="100000"/>
-              </a:lnSpc>
-            </a:pPr>
-            <a:r>
-              <a:rPr sz="1400" b="1" i="0">
-                <a:solidFill>
-                  <a:srgbClr val="07B2AC"/>
-                </a:solidFill>
-                <a:latin typeface="Montserrat Medium"/>
-              </a:rPr>
-              <a:t>TREMFYA · IBD MARKET</a:t>
-            </a:r>
-          </a:p>
-        </p:txBody>
-      </p:sp>
-      <p:sp>
-        <p:nvSpPr>
-          <p:cNvPr id="5" name="TextBox 4"/>
-          <p:cNvSpPr txBox="1"/>
-          <p:nvPr/>
-        </p:nvSpPr>
-        <p:spPr>
-          <a:xfrm>
-            <a:off x="411480" y="2560320"/>
-            <a:ext cx="10515600" cy="2011680"/>
-          </a:xfrm>
-          <a:prstGeom prst="rect">
-            <a:avLst/>
-          </a:prstGeom>
-          <a:noFill/>
-        </p:spPr>
-        <p:txBody>
-          <a:bodyPr wrap="square" anchor="t" lIns="0" rIns="0" tIns="0" bIns="0">
-            <a:spAutoFit/>
-          </a:bodyPr>
-          <a:lstStyle/>
-          <a:p>
-            <a:pPr algn="l">
-              <a:lnSpc>
-                <a:spcPct val="100000"/>
-              </a:lnSpc>
-            </a:pPr>
-            <a:r>
-              <a:rPr sz="4600" b="1" i="0">
-                <a:solidFill>
-                  <a:srgbClr val="FFFFFF"/>
-                </a:solidFill>
-                <a:latin typeface="Montserrat Medium"/>
-              </a:rPr>
-              <a:t>Tremfya SQ IBD Performance</a:t>
-            </a:r>
-          </a:p>
-        </p:txBody>
-      </p:sp>
-      <p:sp>
-        <p:nvSpPr>
-          <p:cNvPr id="6" name="TextBox 5"/>
-          <p:cNvSpPr txBox="1"/>
-          <p:nvPr/>
-        </p:nvSpPr>
-        <p:spPr>
-          <a:xfrm>
-            <a:off x="429768" y="4114800"/>
-            <a:ext cx="10058400" cy="731520"/>
-          </a:xfrm>
-          <a:prstGeom prst="rect">
-            <a:avLst/>
-          </a:prstGeom>
-          <a:noFill/>
-        </p:spPr>
-        <p:txBody>
-          <a:bodyPr wrap="square" anchor="t" lIns="0" rIns="0" tIns="0" bIns="0">
-            <a:spAutoFit/>
-          </a:bodyPr>
-          <a:lstStyle/>
-          <a:p>
-            <a:pPr algn="l">
-              <a:lnSpc>
-                <a:spcPct val="100000"/>
-              </a:lnSpc>
-            </a:pPr>
-            <a:r>
-              <a:rPr sz="1800" b="0" i="1">
-                <a:solidFill>
-                  <a:srgbClr val="D9DEE8"/>
-                </a:solidFill>
-                <a:latin typeface="Roboto"/>
-              </a:rPr>
-              <a:t>Weekly TRx split by indication (UC / CD), full series</a:t>
-            </a:r>
-          </a:p>
-        </p:txBody>
-      </p:sp>
-      <p:sp>
-        <p:nvSpPr>
-          <p:cNvPr id="7" name="TextBox 6"/>
-          <p:cNvSpPr txBox="1"/>
-          <p:nvPr/>
-        </p:nvSpPr>
-        <p:spPr>
-          <a:xfrm>
-            <a:off x="411480" y="6437376"/>
-            <a:ext cx="3657600" cy="274320"/>
-          </a:xfrm>
-          <a:prstGeom prst="rect">
-            <a:avLst/>
-          </a:prstGeom>
-          <a:noFill/>
-        </p:spPr>
-        <p:txBody>
-          <a:bodyPr wrap="square" anchor="t" lIns="0" rIns="0" tIns="0" bIns="0">
-            <a:spAutoFit/>
-          </a:bodyPr>
-          <a:lstStyle/>
-          <a:p>
-            <a:pPr algn="l">
-              <a:lnSpc>
-                <a:spcPct val="100000"/>
-              </a:lnSpc>
-            </a:pPr>
-            <a:r>
-              <a:rPr sz="1100" b="1" i="0">
-                <a:solidFill>
-                  <a:srgbClr val="E40D62"/>
-                </a:solidFill>
-                <a:latin typeface="Montserrat Medium"/>
-              </a:rPr>
-              <a:t>▶ </a:t>
-            </a:r>
-            <a:r>
-              <a:rPr sz="1100" b="1" i="0">
-                <a:solidFill>
-                  <a:srgbClr val="FFFFFF"/>
-                </a:solidFill>
-                <a:latin typeface="Montserrat Medium"/>
-              </a:rPr>
-              <a:t>DataZymes</a:t>
-            </a:r>
-          </a:p>
-        </p:txBody>
-      </p:sp>
-      <p:sp>
-        <p:nvSpPr>
-          <p:cNvPr id="8" name="TextBox 7"/>
-          <p:cNvSpPr txBox="1"/>
-          <p:nvPr/>
-        </p:nvSpPr>
-        <p:spPr>
-          <a:xfrm>
-            <a:off x="11338560" y="6437376"/>
-            <a:ext cx="457200" cy="274320"/>
-          </a:xfrm>
-          <a:prstGeom prst="rect">
-            <a:avLst/>
-          </a:prstGeom>
-          <a:noFill/>
-        </p:spPr>
-        <p:txBody>
-          <a:bodyPr wrap="square" anchor="t" lIns="0" rIns="0" tIns="0" bIns="0">
-            <a:spAutoFit/>
-          </a:bodyPr>
-          <a:lstStyle/>
-          <a:p>
-            <a:pPr algn="r">
-              <a:lnSpc>
-                <a:spcPct val="100000"/>
-              </a:lnSpc>
-            </a:pPr>
-            <a:r>
-              <a:rPr sz="1100" b="0" i="0">
-                <a:solidFill>
-                  <a:srgbClr val="FFFFFF"/>
-                </a:solidFill>
-                <a:latin typeface="Roboto"/>
-              </a:rPr>
-              <a:t>9</a:t>
-            </a:r>
-          </a:p>
-        </p:txBody>
-      </p:sp>
-    </p:spTree>
-  </p:cSld>
-  <p:clrMapOvr>
-    <a:masterClrMapping/>
-  </p:clrMapOvr>
-</p:sld>
-</file>
-
-<file path=ppt/slides/slide2.xml><?xml version="1.0" encoding="utf-8"?>
-<p:sld xmlns:a="http://schemas.openxmlformats.org/drawingml/2006/main" xmlns:p="http://schemas.openxmlformats.org/presentationml/2006/main" xmlns:r="http://schemas.openxmlformats.org/officeDocument/2006/relationships">
-  <p:cSld>
-    <p:spTree>
-      <p:nvGrpSpPr>
-        <p:cNvPr id="1" name=""/>
-        <p:cNvGrpSpPr/>
-        <p:nvPr/>
-      </p:nvGrpSpPr>
-      <p:grpSpPr/>
-      <p:sp>
-        <p:nvSpPr>
-          <p:cNvPr id="2" name="Rectangle 1"/>
-          <p:cNvSpPr/>
-          <p:nvPr/>
-        </p:nvSpPr>
-        <p:spPr>
-          <a:xfrm>
-            <a:off x="0" y="0"/>
-            <a:ext cx="12191695" cy="6858000"/>
-          </a:xfrm>
-          <a:prstGeom prst="rect">
-            <a:avLst/>
-          </a:prstGeom>
-          <a:solidFill>
             <a:srgbClr val="FFFFFF"/>
           </a:solidFill>
           <a:ln>
@@ -5751,7 +5440,7 @@
                 </a:solidFill>
                 <a:latin typeface="Roboto"/>
               </a:rPr>
-              <a:t>10</a:t>
+              <a:t>1</a:t>
             </a:r>
           </a:p>
         </p:txBody>

</xml_diff>